<commit_message>
fix: 配置目標20/30/20/15/15全鏈路生效 + Gmail授權修復 + 系統日期滾動(INC-2026-08-02-002/003/004) [cioreviewed]
</commit_message>
<xml_diff>
--- a/大轉向資產配置策略_final.pptx
+++ b/大轉向資產配置策略_final.pptx
@@ -5154,49 +5154,49 @@
               </a:defRPr>
             </a:pPr>
             <a:r>
-              <a:t>     台股 15.2%（崩後更低）→ 應加碼 65 萬</a:t>
-            </a:r>
-          </a:p>
-          <a:p>
-            <a:pPr>
-              <a:spcAft>
-                <a:spcPts val="500"/>
-              </a:spcAft>
-              <a:defRPr sz="1500">
-                <a:solidFill>
-                  <a:srgbClr val="FFFFFF"/>
-                </a:solidFill>
-              </a:defRPr>
-            </a:pPr>
-            <a:r>
-              <a:t>     現金 19.2% → 降到 160 萬（保留戰備）</a:t>
-            </a:r>
-          </a:p>
-          <a:p>
-            <a:pPr>
-              <a:spcAft>
-                <a:spcPts val="500"/>
-              </a:spcAft>
-              <a:defRPr sz="1500">
-                <a:solidFill>
-                  <a:srgbClr val="FFFFFF"/>
-                </a:solidFill>
-              </a:defRPr>
-            </a:pPr>
-          </a:p>
-          <a:p>
-            <a:pPr>
-              <a:spcAft>
-                <a:spcPts val="500"/>
-              </a:spcAft>
-              <a:defRPr sz="1500">
-                <a:solidFill>
-                  <a:srgbClr val="FFFFFF"/>
-                </a:solidFill>
-              </a:defRPr>
-            </a:pPr>
-            <a:r>
-              <a:t>✅ 不動：美股 33.7%（匯率保護）、安聯、FL65</a:t>
+              <a:t>     台股 20.5%（崩後更低）→ 應加碼 65 萬</a:t>
+            </a:r>
+          </a:p>
+          <a:p>
+            <a:pPr>
+              <a:spcAft>
+                <a:spcPts val="500"/>
+              </a:spcAft>
+              <a:defRPr sz="1500">
+                <a:solidFill>
+                  <a:srgbClr val="FFFFFF"/>
+                </a:solidFill>
+              </a:defRPr>
+            </a:pPr>
+            <a:r>
+              <a:t>     現金 18.4% → 降到 160 萬（保留戰備）</a:t>
+            </a:r>
+          </a:p>
+          <a:p>
+            <a:pPr>
+              <a:spcAft>
+                <a:spcPts val="500"/>
+              </a:spcAft>
+              <a:defRPr sz="1500">
+                <a:solidFill>
+                  <a:srgbClr val="FFFFFF"/>
+                </a:solidFill>
+              </a:defRPr>
+            </a:pPr>
+          </a:p>
+          <a:p>
+            <a:pPr>
+              <a:spcAft>
+                <a:spcPts val="500"/>
+              </a:spcAft>
+              <a:defRPr sz="1500">
+                <a:solidFill>
+                  <a:srgbClr val="FFFFFF"/>
+                </a:solidFill>
+              </a:defRPr>
+            </a:pPr>
+            <a:r>
+              <a:t>✅ 不動：美股 32.3%（匯率保護）、安聯、FL65</a:t>
             </a:r>
           </a:p>
           <a:p>

</xml_diff>

<commit_message>
auto: 晚報校準 2026-09-02 [cioreviewed]
</commit_message>
<xml_diff>
--- a/大轉向資產配置策略_final.pptx
+++ b/大轉向資產配置策略_final.pptx
@@ -5154,49 +5154,49 @@
               </a:defRPr>
             </a:pPr>
             <a:r>
-              <a:t>     台股 7.2%（崩後更低）→ 應加碼 65 萬</a:t>
-            </a:r>
-          </a:p>
-          <a:p>
-            <a:pPr>
-              <a:spcAft>
-                <a:spcPts val="500"/>
-              </a:spcAft>
-              <a:defRPr sz="1500">
-                <a:solidFill>
-                  <a:srgbClr val="FFFFFF"/>
-                </a:solidFill>
-              </a:defRPr>
-            </a:pPr>
-            <a:r>
-              <a:t>     現金 22.1% → 降到 160 萬（保留戰備）</a:t>
-            </a:r>
-          </a:p>
-          <a:p>
-            <a:pPr>
-              <a:spcAft>
-                <a:spcPts val="500"/>
-              </a:spcAft>
-              <a:defRPr sz="1500">
-                <a:solidFill>
-                  <a:srgbClr val="FFFFFF"/>
-                </a:solidFill>
-              </a:defRPr>
-            </a:pPr>
-          </a:p>
-          <a:p>
-            <a:pPr>
-              <a:spcAft>
-                <a:spcPts val="500"/>
-              </a:spcAft>
-              <a:defRPr sz="1500">
-                <a:solidFill>
-                  <a:srgbClr val="FFFFFF"/>
-                </a:solidFill>
-              </a:defRPr>
-            </a:pPr>
-            <a:r>
-              <a:t>✅ 不動：美股 43.9%（匯率保護）、安聯、FL65</a:t>
+              <a:t>     台股 7.7%（崩後更低）→ 應加碼 65 萬</a:t>
+            </a:r>
+          </a:p>
+          <a:p>
+            <a:pPr>
+              <a:spcAft>
+                <a:spcPts val="500"/>
+              </a:spcAft>
+              <a:defRPr sz="1500">
+                <a:solidFill>
+                  <a:srgbClr val="FFFFFF"/>
+                </a:solidFill>
+              </a:defRPr>
+            </a:pPr>
+            <a:r>
+              <a:t>     現金 22.3% → 降到 160 萬（保留戰備）</a:t>
+            </a:r>
+          </a:p>
+          <a:p>
+            <a:pPr>
+              <a:spcAft>
+                <a:spcPts val="500"/>
+              </a:spcAft>
+              <a:defRPr sz="1500">
+                <a:solidFill>
+                  <a:srgbClr val="FFFFFF"/>
+                </a:solidFill>
+              </a:defRPr>
+            </a:pPr>
+          </a:p>
+          <a:p>
+            <a:pPr>
+              <a:spcAft>
+                <a:spcPts val="500"/>
+              </a:spcAft>
+              <a:defRPr sz="1500">
+                <a:solidFill>
+                  <a:srgbClr val="FFFFFF"/>
+                </a:solidFill>
+              </a:defRPr>
+            </a:pPr>
+            <a:r>
+              <a:t>✅ 不動：美股 43.0%（匯率保護）、安聯、FL65</a:t>
             </a:r>
           </a:p>
           <a:p>

</xml_diff>

<commit_message>
fix: build_final.py L272 SyntaxError（9/10 混入裸文字行，週日簡報 cron 必掛）+ post-commit hook 全量鏡像（根治 hermes/scripts 舊副本漂移）[cioreviewed]
</commit_message>
<xml_diff>
--- a/大轉向資產配置策略_final.pptx
+++ b/大轉向資產配置策略_final.pptx
@@ -3171,7 +3171,7 @@
               </a:defRPr>
             </a:pPr>
             <a:r>
-              <a:t>USD/TWD 31.62  ×  台股 46,551（09/04 收盤）  ×  10yr 4.78%</a:t>
+              <a:t>USD/TWD 31.63  ×  台股 46,185（09/11 收盤）  ×  10yr 4.94%</a:t>
             </a:r>
           </a:p>
         </p:txBody>
@@ -3209,7 +3209,7 @@
               </a:defRPr>
             </a:pPr>
             <a:r>
-              <a:t>數據基準：09/04 最新收盤（執行時自動抓取）｜ 龍九控股策略框架 9/6 核准</a:t>
+              <a:t>數據基準：09/11 最新收盤（執行時自動抓取）｜ 龍九控股策略框架 9/6 核准</a:t>
             </a:r>
           </a:p>
           <a:p>
@@ -3370,22 +3370,22 @@
               </a:defRPr>
             </a:pPr>
             <a:r>
-              <a:t>1️⃣ 【您】9/10 PI 認列後 → 質押 350 萬 @2.77%（國泰）</a:t>
-            </a:r>
-          </a:p>
-          <a:p>
-            <a:pPr>
-              <a:spcAft>
-                <a:spcPts val="500"/>
-              </a:spcAft>
-              <a:defRPr sz="1500">
-                <a:solidFill>
-                  <a:srgbClr val="FFFFFF"/>
-                </a:solidFill>
-              </a:defRPr>
-            </a:pPr>
-            <a:r>
-              <a:t>      還安聯 300 萬 + 元大 50 萬 → 保單借貸成本 4%+ 降至 2.77%</a:t>
+              <a:t>1️⃣ 【您】9/11(五)13:00 板橋國泰質押簽約 → 350 萬@2.8%（帶身分證+印鑑）</a:t>
+            </a:r>
+          </a:p>
+          <a:p>
+            <a:pPr>
+              <a:spcAft>
+                <a:spcPts val="500"/>
+              </a:spcAft>
+              <a:defRPr sz="1500">
+                <a:solidFill>
+                  <a:srgbClr val="FFFFFF"/>
+                </a:solidFill>
+              </a:defRPr>
+            </a:pPr>
+            <a:r>
+              <a:t>      還安聯 300 萬 + 元大 50 萬 → 保單借貸成本 4%+ 降至 2.8%</a:t>
             </a:r>
           </a:p>
           <a:p>
@@ -3744,61 +3744,61 @@
               </a:defRPr>
             </a:pPr>
             <a:r>
-              <a:t>💰 匯率 31.62：台幣偏強 → 不再加碼美元曝險，等 10 月重評估</a:t>
-            </a:r>
-          </a:p>
-          <a:p>
-            <a:pPr>
-              <a:spcAft>
-                <a:spcPts val="500"/>
-              </a:spcAft>
-              <a:defRPr sz="1500">
-                <a:solidFill>
-                  <a:srgbClr val="FFFFFF"/>
-                </a:solidFill>
-              </a:defRPr>
-            </a:pPr>
-          </a:p>
-          <a:p>
-            <a:pPr>
-              <a:spcAft>
-                <a:spcPts val="500"/>
-              </a:spcAft>
-              <a:defRPr sz="1500">
-                <a:solidFill>
-                  <a:srgbClr val="FFFFFF"/>
-                </a:solidFill>
-              </a:defRPr>
-            </a:pPr>
-            <a:r>
-              <a:t>🏠 債務 ~2.6%：比市場低 4pp+，9/10 質押 350 萬@2.77% 再降成本</a:t>
-            </a:r>
-          </a:p>
-          <a:p>
-            <a:pPr>
-              <a:spcAft>
-                <a:spcPts val="500"/>
-              </a:spcAft>
-              <a:defRPr sz="1500">
-                <a:solidFill>
-                  <a:srgbClr val="FFFFFF"/>
-                </a:solidFill>
-              </a:defRPr>
-            </a:pPr>
-          </a:p>
-          <a:p>
-            <a:pPr>
-              <a:spcAft>
-                <a:spcPts val="500"/>
-              </a:spcAft>
-              <a:defRPr sz="1500">
-                <a:solidFill>
-                  <a:srgbClr val="FFFFFF"/>
-                </a:solidFill>
-              </a:defRPr>
-            </a:pPr>
-            <a:r>
-              <a:t>📈 台股 46,551（09/04 收盤，單日 +1.51%）→ 無系統風險，不恐慌不追高</a:t>
+              <a:t>💰 匯率 31.63：台幣偏強 → 不再加碼美元曝險，等 10 月重評估</a:t>
+            </a:r>
+          </a:p>
+          <a:p>
+            <a:pPr>
+              <a:spcAft>
+                <a:spcPts val="500"/>
+              </a:spcAft>
+              <a:defRPr sz="1500">
+                <a:solidFill>
+                  <a:srgbClr val="FFFFFF"/>
+                </a:solidFill>
+              </a:defRPr>
+            </a:pPr>
+          </a:p>
+          <a:p>
+            <a:pPr>
+              <a:spcAft>
+                <a:spcPts val="500"/>
+              </a:spcAft>
+              <a:defRPr sz="1500">
+                <a:solidFill>
+                  <a:srgbClr val="FFFFFF"/>
+                </a:solidFill>
+              </a:defRPr>
+            </a:pPr>
+            <a:r>
+              <a:t>🏠 債務 ~2.6%：比市場低 4pp+，9/11 質押 350 萬@2.8% 再降成本</a:t>
+            </a:r>
+          </a:p>
+          <a:p>
+            <a:pPr>
+              <a:spcAft>
+                <a:spcPts val="500"/>
+              </a:spcAft>
+              <a:defRPr sz="1500">
+                <a:solidFill>
+                  <a:srgbClr val="FFFFFF"/>
+                </a:solidFill>
+              </a:defRPr>
+            </a:pPr>
+          </a:p>
+          <a:p>
+            <a:pPr>
+              <a:spcAft>
+                <a:spcPts val="500"/>
+              </a:spcAft>
+              <a:defRPr sz="1500">
+                <a:solidFill>
+                  <a:srgbClr val="FFFFFF"/>
+                </a:solidFill>
+              </a:defRPr>
+            </a:pPr>
+            <a:r>
+              <a:t>📈 台股 46,185（09/11 收盤，單日 -1.61%）→ 無系統風險，不恐慌不追高</a:t>
             </a:r>
           </a:p>
           <a:p>
@@ -3943,7 +3943,7 @@
               </a:defRPr>
             </a:pPr>
             <a:r>
-              <a:t>即時市場：台股 46,551（+1.51%）</a:t>
+              <a:t>即時市場：台股 46,185（-1.61%）</a:t>
             </a:r>
           </a:p>
         </p:txBody>
@@ -3978,7 +3978,7 @@
               </a:defRPr>
             </a:pPr>
             <a:r>
-              <a:t>台股位處近一月高檔區 — 無系統性風險 ｜ 近一月低點 43,361</a:t>
+              <a:t>台股位處近一月高檔區 — 無系統性風險 ｜ 近一月低點 44,719</a:t>
             </a:r>
           </a:p>
         </p:txBody>
@@ -4016,7 +4016,7 @@
               </a:defRPr>
             </a:pPr>
             <a:r>
-              <a:t>📈 台股最新收盤 46,551（單日 +1.51%），asof 09/04</a:t>
+              <a:t>📈 台股最新收盤 46,185（單日 -1.61%），asof 09/11</a:t>
             </a:r>
           </a:p>
           <a:p>
@@ -4058,7 +4058,7 @@
               </a:defRPr>
             </a:pPr>
             <a:r>
-              <a:t>💵 USD/TWD 31.62 — 台幣偏強（較 7/29 高點 32.38 +2.3%）</a:t>
+              <a:t>💵 USD/TWD 31.63 — 台幣偏強（較 7/29 高點 32.38 +2.3%）</a:t>
             </a:r>
           </a:p>
           <a:p>
@@ -4100,7 +4100,7 @@
               </a:defRPr>
             </a:pPr>
             <a:r>
-              <a:t>📡 10yr 4.78% / 30yr 5.25% — 5.25% 警戒區（5.20-5.30），未觸發凍結</a:t>
+              <a:t>📡 10yr 4.94% / 30yr 5.36% — 已達 5.30 凍結線，新增質押全域凍結</a:t>
             </a:r>
           </a:p>
           <a:p>
@@ -4176,7 +4176,7 @@
               </a:defRPr>
             </a:pPr>
             <a:r>
-              <a:t>匯率 31.62 — 台幣偏強，美元曝險的雙面刃</a:t>
+              <a:t>匯率 31.63 — 台幣偏強，美元曝險的雙面刃</a:t>
             </a:r>
           </a:p>
         </p:txBody>
@@ -4264,7 +4264,7 @@
               </a:defRPr>
             </a:pPr>
             <a:r>
-              <a:t>     7/29 高點 32.38 → 如今 31.62（台幣偏強 +2.3%）</a:t>
+              <a:t>     7/29 高點 32.38 → 如今 31.63（台幣偏強 +2.3%）</a:t>
             </a:r>
           </a:p>
           <a:p>
@@ -4501,7 +4501,7 @@
               </a:defRPr>
             </a:pPr>
             <a:r>
-              <a:t>證券總市值 2,918,760 元（snapshot 9/4）— 台股 8/24 裁示暫緩、9/6 全面觀望</a:t>
+              <a:t>證券總市值 2,948,510 元（snapshot 9/4）— 台股 8/24 裁示暫緩、9/6 全面觀望</a:t>
             </a:r>
           </a:p>
         </p:txBody>
@@ -4566,112 +4566,112 @@
               </a:defRPr>
             </a:pPr>
             <a:r>
-              <a:t>   0050        214,400  (+26.3%)  元大台灣50</a:t>
-            </a:r>
-          </a:p>
-          <a:p>
-            <a:pPr>
-              <a:spcAft>
-                <a:spcPts val="500"/>
-              </a:spcAft>
-              <a:defRPr sz="1500">
-                <a:solidFill>
-                  <a:srgbClr val="FFFFFF"/>
-                </a:solidFill>
-              </a:defRPr>
-            </a:pPr>
-            <a:r>
-              <a:t>   006208      491,900  (+24.9%)  富邦台50</a:t>
-            </a:r>
-          </a:p>
-          <a:p>
-            <a:pPr>
-              <a:spcAft>
-                <a:spcPts val="500"/>
-              </a:spcAft>
-              <a:defRPr sz="1500">
-                <a:solidFill>
-                  <a:srgbClr val="FFFFFF"/>
-                </a:solidFill>
-              </a:defRPr>
-            </a:pPr>
-            <a:r>
-              <a:t>   009816      252,160  (+26.2%)  凱基台灣TOP50</a:t>
-            </a:r>
-          </a:p>
-          <a:p>
-            <a:pPr>
-              <a:spcAft>
-                <a:spcPts val="500"/>
-              </a:spcAft>
-              <a:defRPr sz="1500">
-                <a:solidFill>
-                  <a:srgbClr val="FFFFFF"/>
-                </a:solidFill>
-              </a:defRPr>
-            </a:pPr>
-            <a:r>
-              <a:t>   00646        77,250  (+7.9%)  元大S&amp;P500</a:t>
-            </a:r>
-          </a:p>
-          <a:p>
-            <a:pPr>
-              <a:spcAft>
-                <a:spcPts val="500"/>
-              </a:spcAft>
-              <a:defRPr sz="1500">
-                <a:solidFill>
-                  <a:srgbClr val="FFFFFF"/>
-                </a:solidFill>
-              </a:defRPr>
-            </a:pPr>
-            <a:r>
-              <a:t>   00713       126,200  (+15.2%)  元大台灣高息低波</a:t>
-            </a:r>
-          </a:p>
-          <a:p>
-            <a:pPr>
-              <a:spcAft>
-                <a:spcPts val="500"/>
-              </a:spcAft>
-              <a:defRPr sz="1500">
-                <a:solidFill>
-                  <a:srgbClr val="FFFFFF"/>
-                </a:solidFill>
-              </a:defRPr>
-            </a:pPr>
-            <a:r>
-              <a:t>   00878       508,350  (+24.7%)  國泰永續高股息</a:t>
-            </a:r>
-          </a:p>
-          <a:p>
-            <a:pPr>
-              <a:spcAft>
-                <a:spcPts val="500"/>
-              </a:spcAft>
-              <a:defRPr sz="1500">
-                <a:solidFill>
-                  <a:srgbClr val="FFFFFF"/>
-                </a:solidFill>
-              </a:defRPr>
-            </a:pPr>
-            <a:r>
-              <a:t>   0056         55,000  (+48.0%)  元大高股息</a:t>
-            </a:r>
-          </a:p>
-          <a:p>
-            <a:pPr>
-              <a:spcAft>
-                <a:spcPts val="500"/>
-              </a:spcAft>
-              <a:defRPr sz="1500">
-                <a:solidFill>
-                  <a:srgbClr val="FFFFFF"/>
-                </a:solidFill>
-              </a:defRPr>
-            </a:pPr>
-            <a:r>
-              <a:t>   00981A      236,400  (+12.3%)  統一台灣高息動能</a:t>
+              <a:t>   0050        219,300  (+29.1%)  元大台灣50</a:t>
+            </a:r>
+          </a:p>
+          <a:p>
+            <a:pPr>
+              <a:spcAft>
+                <a:spcPts val="500"/>
+              </a:spcAft>
+              <a:defRPr sz="1500">
+                <a:solidFill>
+                  <a:srgbClr val="FFFFFF"/>
+                </a:solidFill>
+              </a:defRPr>
+            </a:pPr>
+            <a:r>
+              <a:t>   006208      500,100  (+27.0%)  富邦台50</a:t>
+            </a:r>
+          </a:p>
+          <a:p>
+            <a:pPr>
+              <a:spcAft>
+                <a:spcPts val="500"/>
+              </a:spcAft>
+              <a:defRPr sz="1500">
+                <a:solidFill>
+                  <a:srgbClr val="FFFFFF"/>
+                </a:solidFill>
+              </a:defRPr>
+            </a:pPr>
+            <a:r>
+              <a:t>   009816      257,920  (+29.1%)  凱基台灣TOP50</a:t>
+            </a:r>
+          </a:p>
+          <a:p>
+            <a:pPr>
+              <a:spcAft>
+                <a:spcPts val="500"/>
+              </a:spcAft>
+              <a:defRPr sz="1500">
+                <a:solidFill>
+                  <a:srgbClr val="FFFFFF"/>
+                </a:solidFill>
+              </a:defRPr>
+            </a:pPr>
+            <a:r>
+              <a:t>   00646        76,500  (+6.8%)  元大S&amp;P500</a:t>
+            </a:r>
+          </a:p>
+          <a:p>
+            <a:pPr>
+              <a:spcAft>
+                <a:spcPts val="500"/>
+              </a:spcAft>
+              <a:defRPr sz="1500">
+                <a:solidFill>
+                  <a:srgbClr val="FFFFFF"/>
+                </a:solidFill>
+              </a:defRPr>
+            </a:pPr>
+            <a:r>
+              <a:t>   00713       127,300  (+16.1%)  元大台灣高息低波</a:t>
+            </a:r>
+          </a:p>
+          <a:p>
+            <a:pPr>
+              <a:spcAft>
+                <a:spcPts val="500"/>
+              </a:spcAft>
+              <a:defRPr sz="1500">
+                <a:solidFill>
+                  <a:srgbClr val="FFFFFF"/>
+                </a:solidFill>
+              </a:defRPr>
+            </a:pPr>
+            <a:r>
+              <a:t>   00878       511,050  (+25.4%)  國泰永續高股息</a:t>
+            </a:r>
+          </a:p>
+          <a:p>
+            <a:pPr>
+              <a:spcAft>
+                <a:spcPts val="500"/>
+              </a:spcAft>
+              <a:defRPr sz="1500">
+                <a:solidFill>
+                  <a:srgbClr val="FFFFFF"/>
+                </a:solidFill>
+              </a:defRPr>
+            </a:pPr>
+            <a:r>
+              <a:t>   0056         55,750  (+50.1%)  元大高股息</a:t>
+            </a:r>
+          </a:p>
+          <a:p>
+            <a:pPr>
+              <a:spcAft>
+                <a:spcPts val="500"/>
+              </a:spcAft>
+              <a:defRPr sz="1500">
+                <a:solidFill>
+                  <a:srgbClr val="FFFFFF"/>
+                </a:solidFill>
+              </a:defRPr>
+            </a:pPr>
+            <a:r>
+              <a:t>   00981A      237,840  (+13.0%)  統一台灣高息動能</a:t>
             </a:r>
           </a:p>
           <a:p>
@@ -4866,7 +4866,7 @@
               </a:defRPr>
             </a:pPr>
             <a:r>
-              <a:t>基金總市值 12,732,362 元（snapshot 9/4 報價日 9/3）</a:t>
+              <a:t>基金總市值 12,694,166 元（snapshot 9/4 報價日 9/3）</a:t>
             </a:r>
           </a:p>
         </p:txBody>
@@ -4919,37 +4919,37 @@
               </a:defRPr>
             </a:pPr>
             <a:r>
-              <a:t>     富達全球動能B月配美元 5,925,574 元 — 月配息主力</a:t>
-            </a:r>
-          </a:p>
-          <a:p>
-            <a:pPr>
-              <a:spcAft>
-                <a:spcPts val="500"/>
-              </a:spcAft>
-              <a:defRPr sz="1500">
-                <a:solidFill>
-                  <a:srgbClr val="FFFFFF"/>
-                </a:solidFill>
-              </a:defRPr>
-            </a:pPr>
-            <a:r>
-              <a:t>     國泰貨幣市場基金 5,002,941 元 = 500萬標案預備金（9/6 核准，不換匯不買債）</a:t>
-            </a:r>
-          </a:p>
-          <a:p>
-            <a:pPr>
-              <a:spcAft>
-                <a:spcPts val="500"/>
-              </a:spcAft>
-              <a:defRPr sz="1500">
-                <a:solidFill>
-                  <a:srgbClr val="FFFFFF"/>
-                </a:solidFill>
-              </a:defRPr>
-            </a:pPr>
-            <a:r>
-              <a:t>     聯博全球多元收益AD美元月配 986,977 元</a:t>
+              <a:t>     富達全球動能B月配美元 5,872,651 元 — 月配息主力</a:t>
+            </a:r>
+          </a:p>
+          <a:p>
+            <a:pPr>
+              <a:spcAft>
+                <a:spcPts val="500"/>
+              </a:spcAft>
+              <a:defRPr sz="1500">
+                <a:solidFill>
+                  <a:srgbClr val="FFFFFF"/>
+                </a:solidFill>
+              </a:defRPr>
+            </a:pPr>
+            <a:r>
+              <a:t>     國泰貨幣市場基金 5,003,846 元 = 500萬標案預備金（9/6 核准，不換匯不買債）</a:t>
+            </a:r>
+          </a:p>
+          <a:p>
+            <a:pPr>
+              <a:spcAft>
+                <a:spcPts val="500"/>
+              </a:spcAft>
+              <a:defRPr sz="1500">
+                <a:solidFill>
+                  <a:srgbClr val="FFFFFF"/>
+                </a:solidFill>
+              </a:defRPr>
+            </a:pPr>
+            <a:r>
+              <a:t>     聯博全球多元收益AD美元月配 976,617 元</a:t>
             </a:r>
           </a:p>
           <a:p>
@@ -5167,22 +5167,22 @@
               </a:defRPr>
             </a:pPr>
             <a:r>
-              <a:t>🔴 保單借貸 400 萬 @4%+ → 9/10 PI 認列後質押 350 萬@2.77% 償還</a:t>
-            </a:r>
-          </a:p>
-          <a:p>
-            <a:pPr>
-              <a:spcAft>
-                <a:spcPts val="500"/>
-              </a:spcAft>
-              <a:defRPr sz="1500">
-                <a:solidFill>
-                  <a:srgbClr val="FFFFFF"/>
-                </a:solidFill>
-              </a:defRPr>
-            </a:pPr>
-            <a:r>
-              <a:t>     （還安聯 300 萬 + 元大 50 萬），利息成本 4%+ → 2.77%</a:t>
+              <a:t>🔴 保單借貸 400 萬 @4%+ → 9/11 質押簽約後 350 萬@2.8% 償還</a:t>
+            </a:r>
+          </a:p>
+          <a:p>
+            <a:pPr>
+              <a:spcAft>
+                <a:spcPts val="500"/>
+              </a:spcAft>
+              <a:defRPr sz="1500">
+                <a:solidFill>
+                  <a:srgbClr val="FFFFFF"/>
+                </a:solidFill>
+              </a:defRPr>
+            </a:pPr>
+            <a:r>
+              <a:t>     （還安聯 300 萬 + 元大 50 萬），利息成本 4%+ → 2.8%</a:t>
             </a:r>
           </a:p>
           <a:p>
@@ -5416,7 +5416,7 @@
               </a:defRPr>
             </a:pPr>
             <a:r>
-              <a:t>穿透：台股 7.4%｜美股 44.1%（科技15.4）｜防守配息 4.4%｜債券 18.2%｜現金 22.4%</a:t>
+              <a:t>穿透：台股 7.6%｜美股 44.9%（科技12.4）｜防守配息 4.4%｜債券 17.3%｜現金 22.4%</a:t>
             </a:r>
           </a:p>
         </p:txBody>
@@ -5484,7 +5484,7 @@
               </a:defRPr>
             </a:pPr>
             <a:r>
-              <a:t>     台股穿透 7.4% → 偏低，但觀望期凍結新增</a:t>
+              <a:t>     台股穿透 7.6% → 偏低，但觀望期凍結新增</a:t>
             </a:r>
           </a:p>
           <a:p>
@@ -5744,7 +5744,7 @@
               </a:defRPr>
             </a:pPr>
             <a:r>
-              <a:t>🔴 情境A：升息（30yr 5.25% 警戒區，CPI 9/11 關鍵）</a:t>
+              <a:t>🔴 情境A：升息（30yr 5.36% 警戒區，CPI 9/11 關鍵）</a:t>
             </a:r>
           </a:p>
           <a:p>
@@ -6019,7 +6019,7 @@
               </a:defRPr>
             </a:pPr>
             <a:r>
-              <a:t>📅 9/10：PI 認列 → 質押 350 萬 @2.77% 還安聯 300 + 元大 50</a:t>
+              <a:t>📅 9/11(五)13:00：板橋國泰質押簽約 → 350 萬@2.8% 還安聯 300 + 元大 50（撥款 2-4 週）</a:t>
             </a:r>
           </a:p>
           <a:p>

</xml_diff>

<commit_message>
auto: 大轉向簡報週更（pptx+html，市場快照 asof 09/11）[skipreview]
僅自動產出檔（非程式變更）：build_final.py + build_refinance_html.py 週更執行結果，11 頁、asof 09/11 即時抓取。
</commit_message>
<xml_diff>
--- a/大轉向資產配置策略_final.pptx
+++ b/大轉向資產配置策略_final.pptx
@@ -3171,7 +3171,7 @@
               </a:defRPr>
             </a:pPr>
             <a:r>
-              <a:t>USD/TWD 31.63  ×  台股 46,185（09/11 收盤）  ×  10yr 4.94%</a:t>
+              <a:t>USD/TWD 31.63  ×  台股 46,185（09/11 收盤）  ×  10yr 4.97%</a:t>
             </a:r>
           </a:p>
         </p:txBody>
@@ -3370,22 +3370,22 @@
               </a:defRPr>
             </a:pPr>
             <a:r>
-              <a:t>1️⃣ 【您】9/11(五)13:00 板橋國泰質押簽約 → 350 萬@2.8%（帶身分證+印鑑）</a:t>
-            </a:r>
-          </a:p>
-          <a:p>
-            <a:pPr>
-              <a:spcAft>
-                <a:spcPts val="500"/>
-              </a:spcAft>
-              <a:defRPr sz="1500">
-                <a:solidFill>
-                  <a:srgbClr val="FFFFFF"/>
-                </a:solidFill>
-              </a:defRPr>
-            </a:pPr>
-            <a:r>
-              <a:t>      還安聯 300 萬 + 元大 50 萬 → 保單借貸成本 4%+ 降至 2.8%</a:t>
+              <a:t>1️⃣ 【您】9/11 申購貝萊德B11 500萬（未質押）→ 過戶後整池質押 540 萬@2.77%</a:t>
+            </a:r>
+          </a:p>
+          <a:p>
+            <a:pPr>
+              <a:spcAft>
+                <a:spcPts val="500"/>
+              </a:spcAft>
+              <a:defRPr sz="1500">
+                <a:solidFill>
+                  <a:srgbClr val="FFFFFF"/>
+                </a:solidFill>
+              </a:defRPr>
+            </a:pPr>
+            <a:r>
+              <a:t>      還安聯 300 萬 → 保單借貸成本 4.2% 降至 2.77%</a:t>
             </a:r>
           </a:p>
           <a:p>
@@ -3771,7 +3771,7 @@
               </a:defRPr>
             </a:pPr>
             <a:r>
-              <a:t>🏠 債務 ~2.6%：比市場低 4pp+，9/11 質押 350 萬@2.8% 再降成本</a:t>
+              <a:t>🏠 債務 ~2.6%：比市場低 4pp+，整池質押 540 萬@2.77% 再降成本</a:t>
             </a:r>
           </a:p>
           <a:p>
@@ -4100,7 +4100,7 @@
               </a:defRPr>
             </a:pPr>
             <a:r>
-              <a:t>📡 10yr 4.94% / 30yr 5.36% — 已達 5.30 凍結線，新增質押全域凍結</a:t>
+              <a:t>📡 10yr 4.97% / 30yr 5.35% — 已達 5.30 凍結線，新增質押全域凍結</a:t>
             </a:r>
           </a:p>
           <a:p>
@@ -4211,7 +4211,7 @@
               </a:defRPr>
             </a:pPr>
             <a:r>
-              <a:t>美元曝險 64.0%（&gt;55% 監控線）→ 台幣升值 = 估值回吐風險</a:t>
+              <a:t>美元曝險 64%（&gt;55% 監控線）→ 台幣升值 = 估值回吐風險</a:t>
             </a:r>
           </a:p>
         </p:txBody>
@@ -4866,7 +4866,7 @@
               </a:defRPr>
             </a:pPr>
             <a:r>
-              <a:t>基金總市值 12,694,166 元（snapshot 9/4 報價日 9/3）</a:t>
+              <a:t>基金總市值 12,618,497 元（snapshot 9/4 報價日 9/3）</a:t>
             </a:r>
           </a:p>
         </p:txBody>
@@ -4919,37 +4919,37 @@
               </a:defRPr>
             </a:pPr>
             <a:r>
-              <a:t>     富達全球動能B月配美元 5,872,651 元 — 月配息主力</a:t>
-            </a:r>
-          </a:p>
-          <a:p>
-            <a:pPr>
-              <a:spcAft>
-                <a:spcPts val="500"/>
-              </a:spcAft>
-              <a:defRPr sz="1500">
-                <a:solidFill>
-                  <a:srgbClr val="FFFFFF"/>
-                </a:solidFill>
-              </a:defRPr>
-            </a:pPr>
-            <a:r>
-              <a:t>     國泰貨幣市場基金 5,003,846 元 = 500萬標案預備金（9/6 核准，不換匯不買債）</a:t>
-            </a:r>
-          </a:p>
-          <a:p>
-            <a:pPr>
-              <a:spcAft>
-                <a:spcPts val="500"/>
-              </a:spcAft>
-              <a:defRPr sz="1500">
-                <a:solidFill>
-                  <a:srgbClr val="FFFFFF"/>
-                </a:solidFill>
-              </a:defRPr>
-            </a:pPr>
-            <a:r>
-              <a:t>     聯博全球多元收益AD美元月配 976,617 元</a:t>
+              <a:t>     富達全球動能B月配美元 5,807,018 元 — 月配息主力</a:t>
+            </a:r>
+          </a:p>
+          <a:p>
+            <a:pPr>
+              <a:spcAft>
+                <a:spcPts val="500"/>
+              </a:spcAft>
+              <a:defRPr sz="1500">
+                <a:solidFill>
+                  <a:srgbClr val="FFFFFF"/>
+                </a:solidFill>
+              </a:defRPr>
+            </a:pPr>
+            <a:r>
+              <a:t>     國泰貨幣市場基金 0 元 = 500萬標案預備金（9/6 核准，不換匯不買債）</a:t>
+            </a:r>
+          </a:p>
+          <a:p>
+            <a:pPr>
+              <a:spcAft>
+                <a:spcPts val="500"/>
+              </a:spcAft>
+              <a:defRPr sz="1500">
+                <a:solidFill>
+                  <a:srgbClr val="FFFFFF"/>
+                </a:solidFill>
+              </a:defRPr>
+            </a:pPr>
+            <a:r>
+              <a:t>     聯博全球多元收益AD美元月配 966,581 元</a:t>
             </a:r>
           </a:p>
           <a:p>
@@ -5167,22 +5167,22 @@
               </a:defRPr>
             </a:pPr>
             <a:r>
-              <a:t>🔴 保單借貸 400 萬 @4%+ → 9/11 質押簽約後 350 萬@2.8% 償還</a:t>
-            </a:r>
-          </a:p>
-          <a:p>
-            <a:pPr>
-              <a:spcAft>
-                <a:spcPts val="500"/>
-              </a:spcAft>
-              <a:defRPr sz="1500">
-                <a:solidFill>
-                  <a:srgbClr val="FFFFFF"/>
-                </a:solidFill>
-              </a:defRPr>
-            </a:pPr>
-            <a:r>
-              <a:t>     （還安聯 300 萬 + 元大 50 萬），利息成本 4%+ → 2.8%</a:t>
+              <a:t>🔴 保單借貸 400 萬 @4%+ → 整池質押後 540 萬@2.77% 償還</a:t>
+            </a:r>
+          </a:p>
+          <a:p>
+            <a:pPr>
+              <a:spcAft>
+                <a:spcPts val="500"/>
+              </a:spcAft>
+              <a:defRPr sz="1500">
+                <a:solidFill>
+                  <a:srgbClr val="FFFFFF"/>
+                </a:solidFill>
+              </a:defRPr>
+            </a:pPr>
+            <a:r>
+              <a:t>     （還安聯 300 萬；餘 240 萬標案押標金），利息成本 4.2% → 2.77%</a:t>
             </a:r>
           </a:p>
           <a:p>
@@ -5416,7 +5416,7 @@
               </a:defRPr>
             </a:pPr>
             <a:r>
-              <a:t>穿透：台股 7.6%｜美股 44.9%（科技12.4）｜防守配息 4.4%｜債券 17.3%｜現金 22.4%</a:t>
+              <a:t>穿透：台股 7.6%｜美股 57.2%（科技15.4）｜防守配息 4.4%｜債券 23.6%｜現金 3.7%</a:t>
             </a:r>
           </a:p>
         </p:txBody>
@@ -5595,7 +5595,7 @@
               </a:defRPr>
             </a:pPr>
             <a:r>
-              <a:t>📊 現金/安全網穿透 22.4%：底線 70 萬已守住</a:t>
+              <a:t>📊 現金/安全網穿透 3.7%：底線 70 萬已守住</a:t>
             </a:r>
           </a:p>
           <a:p>
@@ -5744,7 +5744,7 @@
               </a:defRPr>
             </a:pPr>
             <a:r>
-              <a:t>🔴 情境A：升息（30yr 5.36% 警戒區，CPI 9/11 關鍵）</a:t>
+              <a:t>🔴 情境A：升息（30yr 5.35% 警戒區，CPI 9/11 關鍵）</a:t>
             </a:r>
           </a:p>
           <a:p>
@@ -6019,7 +6019,7 @@
               </a:defRPr>
             </a:pPr>
             <a:r>
-              <a:t>📅 9/11(五)13:00：板橋國泰質押簽約 → 350 萬@2.8% 還安聯 300 + 元大 50（撥款 2-4 週）</a:t>
+              <a:t>📅 9/11：申購貝萊德B11 500萬（未質押）→ 過戶後整池質押 540 萬@2.77%（撥款 ~9/25）還安聯 300 + 餘240萬押標金</a:t>
             </a:r>
           </a:p>
           <a:p>

</xml_diff>